<commit_message>
Updated graph pics in ppt
</commit_message>
<xml_diff>
--- a/Final ppt .pptx
+++ b/Final ppt .pptx
@@ -143,6 +143,14 @@
     </p:ext>
   </p:extLst>
 </p:presentation>
+</file>
+
+<file path=ppt/revisionInfo.xml><?xml version="1.0" encoding="utf-8"?>
+<p1510:revInfo xmlns:a="http://schemas.openxmlformats.org/drawingml/2006/main" xmlns:r="http://schemas.openxmlformats.org/officeDocument/2006/relationships" xmlns:p1510="http://schemas.microsoft.com/office/powerpoint/2015/10/main">
+  <p1510:revLst>
+    <p1510:client id="{146BDE12-6E1A-4A34-B1E2-F8A94B21D786}" v="4" dt="2026-09-25T16:26:18.443"/>
+  </p1510:revLst>
+</p1510:revInfo>
 </file>
 
 <file path=ppt/charts/chart1.xml><?xml version="1.0" encoding="utf-8"?>
@@ -1754,6 +1762,45 @@
       </cdr:spPr>
     </cdr:pic>
   </cdr:relSizeAnchor>
+  <cdr:relSizeAnchor xmlns:cdr="http://schemas.openxmlformats.org/drawingml/2006/chartDrawing">
+    <cdr:from>
+      <cdr:x>0</cdr:x>
+      <cdr:y>0</cdr:y>
+    </cdr:from>
+    <cdr:to>
+      <cdr:x>1</cdr:x>
+      <cdr:y>1</cdr:y>
+    </cdr:to>
+    <cdr:pic>
+      <cdr:nvPicPr>
+        <cdr:cNvPr id="4" name="chart">
+          <a:extLst xmlns:a="http://schemas.openxmlformats.org/drawingml/2006/main">
+            <a:ext uri="{FF2B5EF4-FFF2-40B4-BE49-F238E27FC236}">
+              <a16:creationId xmlns:a16="http://schemas.microsoft.com/office/drawing/2014/main" id="{3597AF96-726F-6CFC-E106-6C4873437617}"/>
+            </a:ext>
+          </a:extLst>
+        </cdr:cNvPr>
+        <cdr:cNvPicPr>
+          <a:picLocks xmlns:a="http://schemas.openxmlformats.org/drawingml/2006/main" noChangeAspect="1"/>
+        </cdr:cNvPicPr>
+      </cdr:nvPicPr>
+      <cdr:blipFill>
+        <a:blip xmlns:a="http://schemas.openxmlformats.org/drawingml/2006/main" xmlns:r="http://schemas.openxmlformats.org/officeDocument/2006/relationships" r:embed="rId3"/>
+        <a:stretch xmlns:a="http://schemas.openxmlformats.org/drawingml/2006/main">
+          <a:fillRect/>
+        </a:stretch>
+      </cdr:blipFill>
+      <cdr:spPr>
+        <a:xfrm xmlns:a="http://schemas.openxmlformats.org/drawingml/2006/main">
+          <a:off x="0" y="0"/>
+          <a:ext cx="15742857" cy="6695238"/>
+        </a:xfrm>
+        <a:prstGeom xmlns:a="http://schemas.openxmlformats.org/drawingml/2006/main" prst="rect">
+          <a:avLst/>
+        </a:prstGeom>
+      </cdr:spPr>
+    </cdr:pic>
+  </cdr:relSizeAnchor>
 </c:userShapes>
 </file>
 
@@ -1791,6 +1838,45 @@
         <a:xfrm xmlns:a="http://schemas.openxmlformats.org/drawingml/2006/main">
           <a:off x="0" y="0"/>
           <a:ext cx="6942422" cy="5121084"/>
+        </a:xfrm>
+        <a:prstGeom xmlns:a="http://schemas.openxmlformats.org/drawingml/2006/main" prst="rect">
+          <a:avLst/>
+        </a:prstGeom>
+      </cdr:spPr>
+    </cdr:pic>
+  </cdr:relSizeAnchor>
+  <cdr:relSizeAnchor xmlns:cdr="http://schemas.openxmlformats.org/drawingml/2006/chartDrawing">
+    <cdr:from>
+      <cdr:x>0</cdr:x>
+      <cdr:y>0</cdr:y>
+    </cdr:from>
+    <cdr:to>
+      <cdr:x>1</cdr:x>
+      <cdr:y>1</cdr:y>
+    </cdr:to>
+    <cdr:pic>
+      <cdr:nvPicPr>
+        <cdr:cNvPr id="3" name="chart">
+          <a:extLst xmlns:a="http://schemas.openxmlformats.org/drawingml/2006/main">
+            <a:ext uri="{FF2B5EF4-FFF2-40B4-BE49-F238E27FC236}">
+              <a16:creationId xmlns:a16="http://schemas.microsoft.com/office/drawing/2014/main" id="{300ECCDF-8D3D-98D5-5510-CF515B06EC3F}"/>
+            </a:ext>
+          </a:extLst>
+        </cdr:cNvPr>
+        <cdr:cNvPicPr>
+          <a:picLocks xmlns:a="http://schemas.openxmlformats.org/drawingml/2006/main" noChangeAspect="1"/>
+        </cdr:cNvPicPr>
+      </cdr:nvPicPr>
+      <cdr:blipFill>
+        <a:blip xmlns:a="http://schemas.openxmlformats.org/drawingml/2006/main" xmlns:r="http://schemas.openxmlformats.org/officeDocument/2006/relationships" r:embed="rId2"/>
+        <a:stretch xmlns:a="http://schemas.openxmlformats.org/drawingml/2006/main">
+          <a:fillRect/>
+        </a:stretch>
+      </cdr:blipFill>
+      <cdr:spPr>
+        <a:xfrm xmlns:a="http://schemas.openxmlformats.org/drawingml/2006/main">
+          <a:off x="0" y="0"/>
+          <a:ext cx="15580952" cy="6723809"/>
         </a:xfrm>
         <a:prstGeom xmlns:a="http://schemas.openxmlformats.org/drawingml/2006/main" prst="rect">
           <a:avLst/>
@@ -1842,6 +1928,45 @@
       </cdr:spPr>
     </cdr:pic>
   </cdr:relSizeAnchor>
+  <cdr:relSizeAnchor xmlns:cdr="http://schemas.openxmlformats.org/drawingml/2006/chartDrawing">
+    <cdr:from>
+      <cdr:x>0</cdr:x>
+      <cdr:y>0</cdr:y>
+    </cdr:from>
+    <cdr:to>
+      <cdr:x>1</cdr:x>
+      <cdr:y>1</cdr:y>
+    </cdr:to>
+    <cdr:pic>
+      <cdr:nvPicPr>
+        <cdr:cNvPr id="3" name="chart">
+          <a:extLst xmlns:a="http://schemas.openxmlformats.org/drawingml/2006/main">
+            <a:ext uri="{FF2B5EF4-FFF2-40B4-BE49-F238E27FC236}">
+              <a16:creationId xmlns:a16="http://schemas.microsoft.com/office/drawing/2014/main" id="{436170B8-5C05-FCA1-D93F-AD53BFB336C7}"/>
+            </a:ext>
+          </a:extLst>
+        </cdr:cNvPr>
+        <cdr:cNvPicPr>
+          <a:picLocks xmlns:a="http://schemas.openxmlformats.org/drawingml/2006/main" noChangeAspect="1"/>
+        </cdr:cNvPicPr>
+      </cdr:nvPicPr>
+      <cdr:blipFill>
+        <a:blip xmlns:a="http://schemas.openxmlformats.org/drawingml/2006/main" xmlns:r="http://schemas.openxmlformats.org/officeDocument/2006/relationships" r:embed="rId2"/>
+        <a:stretch xmlns:a="http://schemas.openxmlformats.org/drawingml/2006/main">
+          <a:fillRect/>
+        </a:stretch>
+      </cdr:blipFill>
+      <cdr:spPr>
+        <a:xfrm xmlns:a="http://schemas.openxmlformats.org/drawingml/2006/main">
+          <a:off x="0" y="0"/>
+          <a:ext cx="15723809" cy="6647619"/>
+        </a:xfrm>
+        <a:prstGeom xmlns:a="http://schemas.openxmlformats.org/drawingml/2006/main" prst="rect">
+          <a:avLst/>
+        </a:prstGeom>
+      </cdr:spPr>
+    </cdr:pic>
+  </cdr:relSizeAnchor>
 </c:userShapes>
 </file>
 
@@ -1879,6 +2004,45 @@
         <a:xfrm xmlns:a="http://schemas.openxmlformats.org/drawingml/2006/main">
           <a:off x="0" y="0"/>
           <a:ext cx="7026249" cy="4511431"/>
+        </a:xfrm>
+        <a:prstGeom xmlns:a="http://schemas.openxmlformats.org/drawingml/2006/main" prst="rect">
+          <a:avLst/>
+        </a:prstGeom>
+      </cdr:spPr>
+    </cdr:pic>
+  </cdr:relSizeAnchor>
+  <cdr:relSizeAnchor xmlns:cdr="http://schemas.openxmlformats.org/drawingml/2006/chartDrawing">
+    <cdr:from>
+      <cdr:x>0</cdr:x>
+      <cdr:y>0</cdr:y>
+    </cdr:from>
+    <cdr:to>
+      <cdr:x>1</cdr:x>
+      <cdr:y>1</cdr:y>
+    </cdr:to>
+    <cdr:pic>
+      <cdr:nvPicPr>
+        <cdr:cNvPr id="3" name="chart">
+          <a:extLst xmlns:a="http://schemas.openxmlformats.org/drawingml/2006/main">
+            <a:ext uri="{FF2B5EF4-FFF2-40B4-BE49-F238E27FC236}">
+              <a16:creationId xmlns:a16="http://schemas.microsoft.com/office/drawing/2014/main" id="{FDF4D9DE-9BF7-4F6A-9D2F-7DACE47987FE}"/>
+            </a:ext>
+          </a:extLst>
+        </cdr:cNvPr>
+        <cdr:cNvPicPr>
+          <a:picLocks xmlns:a="http://schemas.openxmlformats.org/drawingml/2006/main" noChangeAspect="1"/>
+        </cdr:cNvPicPr>
+      </cdr:nvPicPr>
+      <cdr:blipFill>
+        <a:blip xmlns:a="http://schemas.openxmlformats.org/drawingml/2006/main" xmlns:r="http://schemas.openxmlformats.org/officeDocument/2006/relationships" r:embed="rId2"/>
+        <a:stretch xmlns:a="http://schemas.openxmlformats.org/drawingml/2006/main">
+          <a:fillRect/>
+        </a:stretch>
+      </cdr:blipFill>
+      <cdr:spPr>
+        <a:xfrm xmlns:a="http://schemas.openxmlformats.org/drawingml/2006/main">
+          <a:off x="0" y="0"/>
+          <a:ext cx="15590476" cy="6666667"/>
         </a:xfrm>
         <a:prstGeom xmlns:a="http://schemas.openxmlformats.org/drawingml/2006/main" prst="rect">
           <a:avLst/>
@@ -4773,7 +4937,7 @@
           <p:nvPr>
             <p:extLst>
               <p:ext uri="{D42A27DB-BD31-4B8C-83A1-F6EECF244321}">
-                <p14:modId xmlns:p14="http://schemas.microsoft.com/office/powerpoint/2010/main" val="1721362310"/>
+                <p14:modId xmlns:p14="http://schemas.microsoft.com/office/powerpoint/2010/main" val="683610955"/>
               </p:ext>
             </p:extLst>
           </p:nvPr>
@@ -4795,7 +4959,7 @@
           <p:nvPr>
             <p:extLst>
               <p:ext uri="{D42A27DB-BD31-4B8C-83A1-F6EECF244321}">
-                <p14:modId xmlns:p14="http://schemas.microsoft.com/office/powerpoint/2010/main" val="3282465082"/>
+                <p14:modId xmlns:p14="http://schemas.microsoft.com/office/powerpoint/2010/main" val="1949782169"/>
               </p:ext>
             </p:extLst>
           </p:nvPr>
@@ -4817,7 +4981,7 @@
           <p:nvPr>
             <p:extLst>
               <p:ext uri="{D42A27DB-BD31-4B8C-83A1-F6EECF244321}">
-                <p14:modId xmlns:p14="http://schemas.microsoft.com/office/powerpoint/2010/main" val="2366505010"/>
+                <p14:modId xmlns:p14="http://schemas.microsoft.com/office/powerpoint/2010/main" val="3500244387"/>
               </p:ext>
             </p:extLst>
           </p:nvPr>
@@ -4839,7 +5003,7 @@
           <p:nvPr>
             <p:extLst>
               <p:ext uri="{D42A27DB-BD31-4B8C-83A1-F6EECF244321}">
-                <p14:modId xmlns:p14="http://schemas.microsoft.com/office/powerpoint/2010/main" val="414065861"/>
+                <p14:modId xmlns:p14="http://schemas.microsoft.com/office/powerpoint/2010/main" val="2162066899"/>
               </p:ext>
             </p:extLst>
           </p:nvPr>

</xml_diff>